<commit_message>
Team roles split 50/50; drop the AI-assistant line from the slide footer (README keeps the disclosure)
Co-Authored-By: Claude Opus 5.5 <noreply@anthropic.com>
</commit_message>
<xml_diff>
--- a/docs/pitch/ScamShield_pitch.pptx
+++ b/docs/pitch/ScamShield_pitch.pptx
@@ -116,36 +116,36 @@
   <p:extLst>
     <p:ext uri="{521415D9-36F7-43E2-AB2F-B90AF26B5E84}">
       <p14:sectionLst xmlns:p14="http://schemas.microsoft.com/office/powerpoint/2010/main">
-        <p14:section name="Why" id="{036006e2-abb4-45b8-068e-5bd7f45ddb7a}">
+        <p14:section name="Why" id="{ffbf16e2-13d9-62b3-ec9e-0af7bfd0a2c2}">
           <p14:sldIdLst>
             <p14:sldId id="256"/>
             <p14:sldId id="257"/>
             <p14:sldId id="258"/>
           </p14:sldIdLst>
         </p14:section>
-        <p14:section name="How" id="{2c830d86-9e53-550a-8845-ba5d97efdd1d}">
+        <p14:section name="How" id="{7e2c874f-33ba-af05-a412-a2d03fb711e7}">
           <p14:sldIdLst>
             <p14:sldId id="259"/>
             <p14:sldId id="260"/>
           </p14:sldIdLst>
         </p14:section>
-        <p14:section name="Trust" id="{9f6c1540-52e5-6d00-9453-3133c39ea9cf}">
+        <p14:section name="Trust" id="{275c7de7-8121-019c-49e8-600047ce49d4}">
           <p14:sldIdLst>
             <p14:sldId id="261"/>
           </p14:sldIdLst>
         </p14:section>
-        <p14:section name="Results" id="{ec3499a6-eaa6-a7ff-2105-6088bf174411}">
+        <p14:section name="Results" id="{85091ee7-dd9a-3b0a-34a0-e587e9a71d8f}">
           <p14:sldIdLst>
             <p14:sldId id="262"/>
             <p14:sldId id="263"/>
           </p14:sldIdLst>
         </p14:section>
-        <p14:section name="Responsible AI" id="{6f083f39-4a99-7904-36a1-df18bcfd1619}">
+        <p14:section name="Responsible AI" id="{ab826356-9fd2-a740-8310-04b4010e6bbc}">
           <p14:sldIdLst>
             <p14:sldId id="264"/>
           </p14:sldIdLst>
         </p14:section>
-        <p14:section name="Impact" id="{c7faf966-ec8a-9c69-8355-91d448a30d83}">
+        <p14:section name="Impact" id="{ee1d3ff9-28ce-1610-195f-21597c5095c8}">
           <p14:sldIdLst>
             <p14:sldId id="265"/>
           </p14:sldIdLst>
@@ -648,9 +648,8 @@
               <a:t>TIME 4:45–5:00
 SAY:
 "ScamShield checks every payment before it leaves and breaks the mule chain early. Customers get a clear warning, and analysts spend their time where three in four cases are real.
-I'm Soham Athawale, the team lead, and I [say what you built]. My teammate Vaishnavi Joshi [say what Vaishnavi built].
+I'm Soham Athawale, the team lead. I built the LinuxONE infrastructure and containers, the Telum II benchmarks, and the scoring API with its security and audit chain. My teammate Vaishnavi Joshi built the features and both models, the fairness audit, the dashboard and Granite messages, and this pitch.
 Thanks for watching."
-BEFORE RECORDING: replace the two [ ] role lines on this slide and in this script.
 </a:t>
             </a:r>
             <a:endParaRPr lang="en-US" dirty="0"/>
@@ -3055,7 +3054,7 @@
                   <a:srgbClr val="B8C4D6"/>
                 </a:solidFill>
               </a:rPr>
-              <a:t>Team lead · [what Soham built]</a:t>
+              <a:t>Team lead · LinuxONE VM and containers, Telum II benchmarks, scoring API, security and audit chain</a:t>
             </a:r>
             <a:endParaRPr lang="en-US" sz="1500" dirty="0"/>
           </a:p>
@@ -3150,7 +3149,7 @@
                   <a:srgbClr val="B8C4D6"/>
                 </a:solidFill>
               </a:rPr>
-              <a:t>[what Vaishnavi built]</a:t>
+              <a:t>Features and both models, fairness audit, dashboard and Granite messages, pitch</a:t>
             </a:r>
             <a:endParaRPr lang="en-US" sz="1500" dirty="0"/>
           </a:p>
@@ -3188,7 +3187,7 @@
                   <a:schemeClr val="accent5"/>
                 </a:solidFill>
               </a:rPr>
-              <a:t>Code written during the datathon (Oct 17–18) with help from Claude Code, an AI coding assistant · public data</a:t>
+              <a:t>All code written during the IBM Z Datathon 2026 (Oct 17–18) · public data, open-source libraries</a:t>
             </a:r>
             <a:endParaRPr lang="en-US" sz="1100" dirty="0"/>
           </a:p>

</xml_diff>